<commit_message>
docs: point every surface at the td-devpost-agentic-cinema repo
</commit_message>
<xml_diff>
--- a/docs/Customs-submission-deck.pptx
+++ b/docs/Customs-submission-deck.pptx
@@ -3869,13 +3869,13 @@
               </a:lnSpc>
             </a:pPr>
             <a:r>
-              <a:rPr sz="1800" b="1">
+              <a:rPr sz="1500" b="1">
                 <a:solidFill>
                   <a:srgbClr val="E8EEF4"/>
                 </a:solidFill>
                 <a:latin typeface="Menlo"/>
               </a:rPr>
-              <a:t>github.com/tdries/customs</a:t>
+              <a:t>github.com/tdries/td-devpost-agentic-cinema</a:t>
             </a:r>
           </a:p>
           <a:p>

</xml_diff>